<commit_message>
Aula 3: quinto padrao de falha (o hamburguer que sumiu)
Adicionado como slide 17, entre o truncamento e o fechamento da secao 3.4.
Diferente dos outros quatro -- que sao cada um uma falha DENTRO de uma
interacao -- este e' o primeiro em que toda interacao, isolada, passa limpa:
o modelo classificou certo 4 de 4 vezes, e mesmo assim o resultado liquido
foi zero (o hamburguer preparado nunca entrou no estoque). Reforca o
objetivo oficial do video 3.3 (variacoes de qualidade ao longo do tempo --
so aparece olhando a sequencia) e fecha a aula com o gancho mais forte
possivel pra Aula 4.

Renumerados os slides 18-20 -> 19-21 (divisor 3.5, o que aprendemos,
fechamento), com a fala ajustada pra citar cinco falhas em vez de quatro.

slides/gerador-alura/conteudo-aula3.js atualizado e aula3-alura.pptx
regerado: 21 slides (era 20), validado.

Co-Authored-By: Claude Sonnet 5 <noreply@anthropic.com>
</commit_message>
<xml_diff>
--- a/slides/aula3-alura.pptx
+++ b/slides/aula3-alura.pptx
@@ -25,9 +25,10 @@
     <p:sldId id="273" r:id="rId19"/>
     <p:sldId id="274" r:id="rId20"/>
     <p:sldId id="275" r:id="rId21"/>
+    <p:sldId id="276" r:id="rId22"/>
   </p:sldIdLst>
   <p:notesMasterIdLst>
-    <p:notesMasterId r:id="rId22"/>
+    <p:notesMasterId r:id="rId23"/>
   </p:notesMasterIdLst>
   <p:sldSz cx="24387048" cy="13716000"/>
   <p:notesSz cx="13716000" cy="24387048"/>
@@ -1313,7 +1314,7 @@
           <a:p>
             <a:r>
               <a:rPr lang="en-US" dirty="0"/>
-              <a:t>CLAQUETE — inicio do video 3.5. Segure 2 segundos em silencio antes de comecar a falar: e por esta tela que a edicao corta.</a:t>
+              <a:t/>
             </a:r>
             <a:endParaRPr lang="en-US" dirty="0"/>
           </a:p>
@@ -1401,7 +1402,7 @@
           <a:p>
             <a:r>
               <a:rPr lang="en-US" dirty="0"/>
-              <a:t/>
+              <a:t>CLAQUETE — inicio do video 3.5. Segure 2 segundos em silencio antes de comecar a falar: e por esta tela que a edicao corta.</a:t>
             </a:r>
             <a:endParaRPr lang="en-US" dirty="0"/>
           </a:p>
@@ -1601,6 +1602,94 @@
             <a:fld id="{F7021451-1387-4CA6-816F-3879F97B5CBC}" type="slidenum">
               <a:rPr lang="en-US"/>
               <a:t>20</a:t>
+            </a:fld>
+            <a:endParaRPr lang="en-US"/>
+          </a:p>
+        </p:txBody>
+      </p:sp>
+    </p:spTree>
+    <p:extLst>
+      <p:ext uri="{BB962C8B-B14F-4D97-AF65-F5344CB8AC3E}">
+        <p14:creationId xmlns:p14="http://schemas.microsoft.com/office/powerpoint/2010/main" val="1024086991"/>
+      </p:ext>
+    </p:extLst>
+  </p:cSld>
+  <p:clrMapOvr>
+    <a:masterClrMapping/>
+  </p:clrMapOvr>
+</p:notes>
+</file>
+
+<file path=ppt/notesSlides/notesSlide21.xml><?xml version="1.0" encoding="utf-8"?>
+<p:notes xmlns:a="http://schemas.openxmlformats.org/drawingml/2006/main" xmlns:r="http://schemas.openxmlformats.org/officeDocument/2006/relationships" xmlns:p="http://schemas.openxmlformats.org/presentationml/2006/main">
+  <p:cSld>
+    <p:spTree>
+      <p:nvGrpSpPr>
+        <p:cNvPr id="1" name=""/>
+        <p:cNvGrpSpPr/>
+        <p:nvPr/>
+      </p:nvGrpSpPr>
+      <p:grpSpPr>
+        <a:xfrm>
+          <a:off x="0" y="0"/>
+          <a:ext cx="0" cy="0"/>
+          <a:chOff x="0" y="0"/>
+          <a:chExt cx="0" cy="0"/>
+        </a:xfrm>
+      </p:grpSpPr>
+      <p:sp>
+        <p:nvSpPr>
+          <p:cNvPr id="2" name="Slide Image Placeholder 1"/>
+          <p:cNvSpPr>
+            <a:spLocks noGrp="1" noRot="1" noChangeAspect="1"/>
+          </p:cNvSpPr>
+          <p:nvPr>
+            <p:ph type="sldImg"/>
+          </p:nvPr>
+        </p:nvSpPr>
+        <p:spPr/>
+      </p:sp>
+      <p:sp>
+        <p:nvSpPr>
+          <p:cNvPr id="3" name="Notes Placeholder 2"/>
+          <p:cNvSpPr>
+            <a:spLocks noGrp="1"/>
+          </p:cNvSpPr>
+          <p:nvPr>
+            <p:ph type="body" idx="1"/>
+          </p:nvPr>
+        </p:nvSpPr>
+        <p:spPr/>
+        <p:txBody>
+          <a:bodyPr/>
+          <a:lstStyle/>
+          <a:p>
+            <a:r>
+              <a:rPr lang="en-US" dirty="0"/>
+              <a:t/>
+            </a:r>
+            <a:endParaRPr lang="en-US" dirty="0"/>
+          </a:p>
+        </p:txBody>
+      </p:sp>
+      <p:sp>
+        <p:nvSpPr>
+          <p:cNvPr id="4" name="Slide Number Placeholder 3"/>
+          <p:cNvSpPr>
+            <a:spLocks noGrp="1"/>
+          </p:cNvSpPr>
+          <p:nvPr>
+            <p:ph type="sldNum" sz="quarter" idx="10"/>
+          </p:nvPr>
+        </p:nvSpPr>
+        <p:spPr/>
+        <p:txBody>
+          <a:bodyPr/>
+          <a:lstStyle/>
+          <a:p>
+            <a:fld id="{F7021451-1387-4CA6-816F-3879F97B5CBC}" type="slidenum">
+              <a:rPr lang="en-US"/>
+              <a:t>21</a:t>
             </a:fld>
             <a:endParaRPr lang="en-US"/>
           </a:p>
@@ -6328,7 +6417,7 @@
                 <a:ea typeface="Encode Sans" pitchFamily="34" charset="-122"/>
                 <a:cs typeface="Encode Sans" pitchFamily="34" charset="-120"/>
               </a:rPr>
-              <a:t>Quatro falhas que eu achei olhando</a:t>
+              <a:t>Cinco falhas que eu achei olhando</a:t>
             </a:r>
             <a:endParaRPr lang="en-US" sz="6600" dirty="0"/>
           </a:p>
@@ -6370,7 +6459,7 @@
         </p:blipFill>
         <p:spPr>
           <a:xfrm>
-            <a:off x="2423160" y="6094476"/>
+            <a:off x="2423160" y="5385816"/>
             <a:ext cx="475488" cy="411480"/>
           </a:xfrm>
           <a:prstGeom prst="rect">
@@ -6386,7 +6475,7 @@
         </p:nvSpPr>
         <p:spPr>
           <a:xfrm>
-            <a:off x="3337560" y="5966460"/>
+            <a:off x="3337560" y="5257800"/>
             <a:ext cx="17922240" cy="548640"/>
           </a:xfrm>
           <a:prstGeom prst="rect">
@@ -6436,7 +6525,7 @@
         </p:blipFill>
         <p:spPr>
           <a:xfrm>
-            <a:off x="2423160" y="7648956"/>
+            <a:off x="2423160" y="6906006"/>
             <a:ext cx="475488" cy="411480"/>
           </a:xfrm>
           <a:prstGeom prst="rect">
@@ -6452,7 +6541,7 @@
         </p:nvSpPr>
         <p:spPr>
           <a:xfrm>
-            <a:off x="3337560" y="7520940"/>
+            <a:off x="3337560" y="6777990"/>
             <a:ext cx="17922240" cy="548640"/>
           </a:xfrm>
           <a:prstGeom prst="rect">
@@ -6502,7 +6591,7 @@
         </p:blipFill>
         <p:spPr>
           <a:xfrm>
-            <a:off x="2423160" y="9203436"/>
+            <a:off x="2423160" y="8426196"/>
             <a:ext cx="475488" cy="411480"/>
           </a:xfrm>
           <a:prstGeom prst="rect">
@@ -6518,7 +6607,7 @@
         </p:nvSpPr>
         <p:spPr>
           <a:xfrm>
-            <a:off x="3337560" y="9075420"/>
+            <a:off x="3337560" y="8298180"/>
             <a:ext cx="17922240" cy="548640"/>
           </a:xfrm>
           <a:prstGeom prst="rect">
@@ -6568,7 +6657,7 @@
         </p:blipFill>
         <p:spPr>
           <a:xfrm>
-            <a:off x="2423160" y="10757916"/>
+            <a:off x="2423160" y="9946386"/>
             <a:ext cx="475488" cy="411480"/>
           </a:xfrm>
           <a:prstGeom prst="rect">
@@ -6584,7 +6673,73 @@
         </p:nvSpPr>
         <p:spPr>
           <a:xfrm>
-            <a:off x="3337560" y="10629900"/>
+            <a:off x="3337560" y="9818370"/>
+            <a:ext cx="17922240" cy="548640"/>
+          </a:xfrm>
+          <a:prstGeom prst="rect">
+            <a:avLst/>
+          </a:prstGeom>
+          <a:noFill/>
+          <a:ln/>
+        </p:spPr>
+        <p:txBody>
+          <a:bodyPr wrap="square" lIns="0" tIns="0" rIns="0" bIns="0" rtlCol="0" anchor="t"/>
+          <a:lstStyle/>
+          <a:p>
+            <a:pPr indent="0" marL="0">
+              <a:lnSpc>
+                <a:spcPct val="118000"/>
+              </a:lnSpc>
+              <a:buNone/>
+            </a:pPr>
+            <a:r>
+              <a:rPr lang="en-US" sz="2800" dirty="0">
+                <a:solidFill>
+                  <a:srgbClr val="A7A9B4"/>
+                </a:solidFill>
+                <a:latin typeface="Roboto" pitchFamily="34" charset="0"/>
+                <a:ea typeface="Roboto" pitchFamily="34" charset="-122"/>
+                <a:cs typeface="Roboto" pitchFamily="34" charset="-120"/>
+              </a:rPr>
+              <a:t>Uma em que a inteligência acertou tudo, e mesmo assim o estoque ficou errado.</a:t>
+            </a:r>
+            <a:endParaRPr lang="en-US" sz="2800" dirty="0"/>
+          </a:p>
+        </p:txBody>
+      </p:sp>
+      <p:pic>
+        <p:nvPicPr>
+          <p:cNvPr id="15" name="Image 6" descr="art\seta.png">    </p:cNvPr>
+          <p:cNvPicPr>
+            <a:picLocks noChangeAspect="1"/>
+          </p:cNvPicPr>
+          <p:nvPr/>
+        </p:nvPicPr>
+        <p:blipFill>
+          <a:blip r:embed="rId7"/>
+          <a:stretch>
+            <a:fillRect/>
+          </a:stretch>
+        </p:blipFill>
+        <p:spPr>
+          <a:xfrm>
+            <a:off x="2423160" y="11466576"/>
+            <a:ext cx="475488" cy="411480"/>
+          </a:xfrm>
+          <a:prstGeom prst="rect">
+            <a:avLst/>
+          </a:prstGeom>
+        </p:spPr>
+      </p:pic>
+      <p:sp>
+        <p:nvSpPr>
+          <p:cNvPr id="16" name="Text 7"/>
+          <p:cNvSpPr txBox="1"/>
+          <p:nvPr/>
+        </p:nvSpPr>
+        <p:spPr>
+          <a:xfrm>
+            <a:off x="3337560" y="11338560"/>
             <a:ext cx="17922240" cy="548640"/>
           </a:xfrm>
           <a:prstGeom prst="rect">
@@ -6612,7 +6767,7 @@
                 <a:ea typeface="Roboto" pitchFamily="34" charset="-122"/>
                 <a:cs typeface="Roboto" pitchFamily="34" charset="-120"/>
               </a:rPr>
-              <a:t>E uma em que a inteligência acertou tudo, e mesmo assim o estoque ficou errado.</a:t>
+              <a:t>E uma quinta, achada ontem à noite, cozinhando de verdade — diferente de todas as outras.</a:t>
             </a:r>
             <a:endParaRPr lang="en-US" sz="2800" dirty="0"/>
           </a:p>
@@ -6620,7 +6775,7 @@
       </p:sp>
       <p:sp>
         <p:nvSpPr>
-          <p:cNvPr id="15" name="Text 7"/>
+          <p:cNvPr id="17" name="Text 8"/>
           <p:cNvSpPr txBox="1"/>
           <p:nvPr/>
         </p:nvSpPr>
@@ -7192,7 +7347,7 @@
                 <a:ea typeface="Encode Sans" pitchFamily="34" charset="-122"/>
                 <a:cs typeface="Encode Sans" pitchFamily="34" charset="-120"/>
               </a:rPr>
-              <a:t>VÍDEO 3.4</a:t>
+              <a:t>VÍDEO 3.4 — 14/09, AO VIVO</a:t>
             </a:r>
             <a:endParaRPr lang="en-US" sz="2100" dirty="0"/>
           </a:p>
@@ -7234,7 +7389,7 @@
                 <a:ea typeface="Encode Sans" pitchFamily="34" charset="-122"/>
                 <a:cs typeface="Encode Sans" pitchFamily="34" charset="-120"/>
               </a:rPr>
-              <a:t>O que as quatro têm em comum</a:t>
+              <a:t>O hambúrguer que sumiu</a:t>
             </a:r>
             <a:endParaRPr lang="en-US" sz="6600" dirty="0"/>
           </a:p>
@@ -7293,6 +7448,72 @@
         <p:spPr>
           <a:xfrm>
             <a:off x="3337560" y="6743700"/>
+            <a:ext cx="17922240" cy="548640"/>
+          </a:xfrm>
+          <a:prstGeom prst="rect">
+            <a:avLst/>
+          </a:prstGeom>
+          <a:noFill/>
+          <a:ln/>
+        </p:spPr>
+        <p:txBody>
+          <a:bodyPr wrap="square" lIns="0" tIns="0" rIns="0" bIns="0" rtlCol="0" anchor="t"/>
+          <a:lstStyle/>
+          <a:p>
+            <a:pPr indent="0" marL="0">
+              <a:lnSpc>
+                <a:spcPct val="118000"/>
+              </a:lnSpc>
+              <a:buNone/>
+            </a:pPr>
+            <a:r>
+              <a:rPr lang="en-US" sz="2800" dirty="0">
+                <a:solidFill>
+                  <a:srgbClr val="A7A9B4"/>
+                </a:solidFill>
+                <a:latin typeface="Roboto" pitchFamily="34" charset="0"/>
+                <a:ea typeface="Roboto" pitchFamily="34" charset="-122"/>
+                <a:cs typeface="Roboto" pitchFamily="34" charset="-120"/>
+              </a:rPr>
+              <a:t>Preparei um prato, contei pro bot, respondi a pergunta dele — três vezes, de jeitos diferentes.</a:t>
+            </a:r>
+            <a:endParaRPr lang="en-US" sz="2800" dirty="0"/>
+          </a:p>
+        </p:txBody>
+      </p:sp>
+      <p:pic>
+        <p:nvPicPr>
+          <p:cNvPr id="9" name="Image 3" descr="art\seta.png">    </p:cNvPr>
+          <p:cNvPicPr>
+            <a:picLocks noChangeAspect="1"/>
+          </p:cNvPicPr>
+          <p:nvPr/>
+        </p:nvPicPr>
+        <p:blipFill>
+          <a:blip r:embed="rId4"/>
+          <a:stretch>
+            <a:fillRect/>
+          </a:stretch>
+        </p:blipFill>
+        <p:spPr>
+          <a:xfrm>
+            <a:off x="2423160" y="8426196"/>
+            <a:ext cx="475488" cy="411480"/>
+          </a:xfrm>
+          <a:prstGeom prst="rect">
+            <a:avLst/>
+          </a:prstGeom>
+        </p:spPr>
+      </p:pic>
+      <p:sp>
+        <p:nvSpPr>
+          <p:cNvPr id="10" name="Text 4"/>
+          <p:cNvSpPr txBox="1"/>
+          <p:nvPr/>
+        </p:nvSpPr>
+        <p:spPr>
+          <a:xfrm>
+            <a:off x="3337560" y="8298180"/>
             <a:ext cx="17922240" cy="548640"/>
           </a:xfrm>
           <a:prstGeom prst="rect">
@@ -7320,7 +7541,7 @@
                 <a:ea typeface="Roboto" pitchFamily="34" charset="-122"/>
                 <a:cs typeface="Roboto" pitchFamily="34" charset="-120"/>
               </a:rPr>
-              <a:t>Nenhuma delas gritou.</a:t>
+              <a:t>Fui checar os quatro traces: os quatro estão perfeitos. Zero erro.</a:t>
             </a:r>
             <a:endParaRPr lang="en-US" sz="2800" dirty="0"/>
           </a:p>
@@ -7328,21 +7549,21 @@
       </p:sp>
       <p:pic>
         <p:nvPicPr>
-          <p:cNvPr id="9" name="Image 3" descr="art\seta.png">    </p:cNvPr>
+          <p:cNvPr id="11" name="Image 4" descr="art\seta.png">    </p:cNvPr>
           <p:cNvPicPr>
             <a:picLocks noChangeAspect="1"/>
           </p:cNvPicPr>
           <p:nvPr/>
         </p:nvPicPr>
         <p:blipFill>
-          <a:blip r:embed="rId4"/>
+          <a:blip r:embed="rId5"/>
           <a:stretch>
             <a:fillRect/>
           </a:stretch>
         </p:blipFill>
         <p:spPr>
           <a:xfrm>
-            <a:off x="2423160" y="8426196"/>
+            <a:off x="2423160" y="9980676"/>
             <a:ext cx="475488" cy="411480"/>
           </a:xfrm>
           <a:prstGeom prst="rect">
@@ -7352,13 +7573,13 @@
       </p:pic>
       <p:sp>
         <p:nvSpPr>
-          <p:cNvPr id="10" name="Text 4"/>
+          <p:cNvPr id="12" name="Text 5"/>
           <p:cNvSpPr txBox="1"/>
           <p:nvPr/>
         </p:nvSpPr>
         <p:spPr>
           <a:xfrm>
-            <a:off x="3337560" y="8298180"/>
+            <a:off x="3337560" y="9852660"/>
             <a:ext cx="17922240" cy="548640"/>
           </a:xfrm>
           <a:prstGeom prst="rect">
@@ -7386,73 +7607,7 @@
                 <a:ea typeface="Roboto" pitchFamily="34" charset="-122"/>
                 <a:cs typeface="Roboto" pitchFamily="34" charset="-120"/>
               </a:rPr>
-              <a:t>Nenhum usuário reclamou de nenhuma das quatro.</a:t>
-            </a:r>
-            <a:endParaRPr lang="en-US" sz="2800" dirty="0"/>
-          </a:p>
-        </p:txBody>
-      </p:sp>
-      <p:pic>
-        <p:nvPicPr>
-          <p:cNvPr id="11" name="Image 4" descr="art\seta.png">    </p:cNvPr>
-          <p:cNvPicPr>
-            <a:picLocks noChangeAspect="1"/>
-          </p:cNvPicPr>
-          <p:nvPr/>
-        </p:nvPicPr>
-        <p:blipFill>
-          <a:blip r:embed="rId5"/>
-          <a:stretch>
-            <a:fillRect/>
-          </a:stretch>
-        </p:blipFill>
-        <p:spPr>
-          <a:xfrm>
-            <a:off x="2423160" y="9980676"/>
-            <a:ext cx="475488" cy="411480"/>
-          </a:xfrm>
-          <a:prstGeom prst="rect">
-            <a:avLst/>
-          </a:prstGeom>
-        </p:spPr>
-      </p:pic>
-      <p:sp>
-        <p:nvSpPr>
-          <p:cNvPr id="12" name="Text 5"/>
-          <p:cNvSpPr txBox="1"/>
-          <p:nvPr/>
-        </p:nvSpPr>
-        <p:spPr>
-          <a:xfrm>
-            <a:off x="3337560" y="9852660"/>
-            <a:ext cx="17922240" cy="548640"/>
-          </a:xfrm>
-          <a:prstGeom prst="rect">
-            <a:avLst/>
-          </a:prstGeom>
-          <a:noFill/>
-          <a:ln/>
-        </p:spPr>
-        <p:txBody>
-          <a:bodyPr wrap="square" lIns="0" tIns="0" rIns="0" bIns="0" rtlCol="0" anchor="t"/>
-          <a:lstStyle/>
-          <a:p>
-            <a:pPr indent="0" marL="0">
-              <a:lnSpc>
-                <a:spcPct val="118000"/>
-              </a:lnSpc>
-              <a:buNone/>
-            </a:pPr>
-            <a:r>
-              <a:rPr lang="en-US" sz="2800" dirty="0">
-                <a:solidFill>
-                  <a:srgbClr val="A7A9B4"/>
-                </a:solidFill>
-                <a:latin typeface="Roboto" pitchFamily="34" charset="0"/>
-                <a:ea typeface="Roboto" pitchFamily="34" charset="-122"/>
-                <a:cs typeface="Roboto" pitchFamily="34" charset="-120"/>
-              </a:rPr>
-              <a:t>Cada uma precisou de alguém olhando o dado certo, com a pergunta certa — e esse alguém é você.</a:t>
+              <a:t>E mesmo assim, o prato nunca entrou no estoque. Resultado líquido zero, sem uma falha visível.</a:t>
             </a:r>
             <a:endParaRPr lang="en-US" sz="2800" dirty="0"/>
           </a:p>
@@ -7510,6 +7665,426 @@
 <file path=ppt/slides/slide18.xml><?xml version="1.0" encoding="utf-8"?>
 <p:sld xmlns:a="http://schemas.openxmlformats.org/drawingml/2006/main" xmlns:r="http://schemas.openxmlformats.org/officeDocument/2006/relationships" xmlns:p="http://schemas.openxmlformats.org/presentationml/2006/main">
   <p:cSld name="Slide 18">
+    <p:bg>
+      <p:bgPr>
+        <a:solidFill>
+          <a:srgbClr val="0C0C0E"/>
+        </a:solidFill>
+      </p:bgPr>
+    </p:bg>
+    <p:spTree>
+      <p:nvGrpSpPr>
+        <p:cNvPr id="1" name=""/>
+        <p:cNvGrpSpPr/>
+        <p:nvPr/>
+      </p:nvGrpSpPr>
+      <p:grpSpPr>
+        <a:xfrm>
+          <a:off x="0" y="0"/>
+          <a:ext cx="0" cy="0"/>
+          <a:chOff x="0" y="0"/>
+          <a:chExt cx="0" cy="0"/>
+        </a:xfrm>
+      </p:grpSpPr>
+      <p:pic>
+        <p:nvPicPr>
+          <p:cNvPr id="2" name="Image 0" descr="art\malha.png">    </p:cNvPr>
+          <p:cNvPicPr>
+            <a:picLocks noChangeAspect="1"/>
+          </p:cNvPicPr>
+          <p:nvPr/>
+        </p:nvPicPr>
+        <p:blipFill>
+          <a:blip r:embed="rId1"/>
+          <a:stretch>
+            <a:fillRect/>
+          </a:stretch>
+        </p:blipFill>
+        <p:spPr>
+          <a:xfrm>
+            <a:off x="0" y="0"/>
+            <a:ext cx="24387048" cy="13716000"/>
+          </a:xfrm>
+          <a:prstGeom prst="rect">
+            <a:avLst/>
+          </a:prstGeom>
+        </p:spPr>
+      </p:pic>
+      <p:pic>
+        <p:nvPicPr>
+          <p:cNvPr id="3" name="Image 1" descr="art\logo.png">    </p:cNvPr>
+          <p:cNvPicPr>
+            <a:picLocks noChangeAspect="1"/>
+          </p:cNvPicPr>
+          <p:nvPr/>
+        </p:nvPicPr>
+        <p:blipFill>
+          <a:blip r:embed="rId2"/>
+          <a:stretch>
+            <a:fillRect/>
+          </a:stretch>
+        </p:blipFill>
+        <p:spPr>
+          <a:xfrm>
+            <a:off x="23436072" y="402336"/>
+            <a:ext cx="475488" cy="594360"/>
+          </a:xfrm>
+          <a:prstGeom prst="rect">
+            <a:avLst/>
+          </a:prstGeom>
+        </p:spPr>
+      </p:pic>
+      <p:sp>
+        <p:nvSpPr>
+          <p:cNvPr id="4" name="Text 0"/>
+          <p:cNvSpPr txBox="1"/>
+          <p:nvPr/>
+        </p:nvSpPr>
+        <p:spPr>
+          <a:xfrm>
+            <a:off x="2423160" y="1051560"/>
+            <a:ext cx="19540728" cy="594360"/>
+          </a:xfrm>
+          <a:prstGeom prst="rect">
+            <a:avLst/>
+          </a:prstGeom>
+          <a:noFill/>
+          <a:ln/>
+        </p:spPr>
+        <p:txBody>
+          <a:bodyPr wrap="square" lIns="0" tIns="0" rIns="0" bIns="0" rtlCol="0" anchor="ctr"/>
+          <a:lstStyle/>
+          <a:p>
+            <a:pPr indent="0" marL="0">
+              <a:buNone/>
+            </a:pPr>
+            <a:r>
+              <a:rPr lang="en-US" sz="2100" b="1" spc="250" kern="0" dirty="0">
+                <a:solidFill>
+                  <a:srgbClr val="1F53E5"/>
+                </a:solidFill>
+                <a:latin typeface="Encode Sans" pitchFamily="34" charset="0"/>
+                <a:ea typeface="Encode Sans" pitchFamily="34" charset="-122"/>
+                <a:cs typeface="Encode Sans" pitchFamily="34" charset="-120"/>
+              </a:rPr>
+              <a:t>VÍDEO 3.4</a:t>
+            </a:r>
+            <a:endParaRPr lang="en-US" sz="2100" dirty="0"/>
+          </a:p>
+        </p:txBody>
+      </p:sp>
+      <p:sp>
+        <p:nvSpPr>
+          <p:cNvPr id="5" name="Text 1"/>
+          <p:cNvSpPr txBox="1"/>
+          <p:nvPr/>
+        </p:nvSpPr>
+        <p:spPr>
+          <a:xfrm>
+            <a:off x="2423160" y="1783080"/>
+            <a:ext cx="19568160" cy="2377440"/>
+          </a:xfrm>
+          <a:prstGeom prst="rect">
+            <a:avLst/>
+          </a:prstGeom>
+          <a:noFill/>
+          <a:ln/>
+        </p:spPr>
+        <p:txBody>
+          <a:bodyPr wrap="square" lIns="0" tIns="0" rIns="0" bIns="0" rtlCol="0" anchor="t"/>
+          <a:lstStyle/>
+          <a:p>
+            <a:pPr indent="0" marL="0">
+              <a:lnSpc>
+                <a:spcPct val="105000"/>
+              </a:lnSpc>
+              <a:buNone/>
+            </a:pPr>
+            <a:r>
+              <a:rPr lang="en-US" sz="6600" dirty="0">
+                <a:solidFill>
+                  <a:srgbClr val="BDBFC7"/>
+                </a:solidFill>
+                <a:latin typeface="Encode Sans" pitchFamily="34" charset="0"/>
+                <a:ea typeface="Encode Sans" pitchFamily="34" charset="-122"/>
+                <a:cs typeface="Encode Sans" pitchFamily="34" charset="-120"/>
+              </a:rPr>
+              <a:t>O que as cinco têm em comum</a:t>
+            </a:r>
+            <a:endParaRPr lang="en-US" sz="6600" dirty="0"/>
+          </a:p>
+        </p:txBody>
+      </p:sp>
+      <p:sp>
+        <p:nvSpPr>
+          <p:cNvPr id="6" name="Shape 2"/>
+          <p:cNvSpPr/>
+          <p:nvPr/>
+        </p:nvSpPr>
+        <p:spPr>
+          <a:xfrm>
+            <a:off x="2423160" y="4526280"/>
+            <a:ext cx="2011680" cy="68580"/>
+          </a:xfrm>
+          <a:prstGeom prst="rect">
+            <a:avLst/>
+          </a:prstGeom>
+          <a:solidFill>
+            <a:srgbClr val="1F53E5"/>
+          </a:solidFill>
+          <a:ln/>
+        </p:spPr>
+      </p:sp>
+      <p:pic>
+        <p:nvPicPr>
+          <p:cNvPr id="7" name="Image 2" descr="art\seta.png">    </p:cNvPr>
+          <p:cNvPicPr>
+            <a:picLocks noChangeAspect="1"/>
+          </p:cNvPicPr>
+          <p:nvPr/>
+        </p:nvPicPr>
+        <p:blipFill>
+          <a:blip r:embed="rId3"/>
+          <a:stretch>
+            <a:fillRect/>
+          </a:stretch>
+        </p:blipFill>
+        <p:spPr>
+          <a:xfrm>
+            <a:off x="2423160" y="6871716"/>
+            <a:ext cx="475488" cy="411480"/>
+          </a:xfrm>
+          <a:prstGeom prst="rect">
+            <a:avLst/>
+          </a:prstGeom>
+        </p:spPr>
+      </p:pic>
+      <p:sp>
+        <p:nvSpPr>
+          <p:cNvPr id="8" name="Text 3"/>
+          <p:cNvSpPr txBox="1"/>
+          <p:nvPr/>
+        </p:nvSpPr>
+        <p:spPr>
+          <a:xfrm>
+            <a:off x="3337560" y="6743700"/>
+            <a:ext cx="17922240" cy="548640"/>
+          </a:xfrm>
+          <a:prstGeom prst="rect">
+            <a:avLst/>
+          </a:prstGeom>
+          <a:noFill/>
+          <a:ln/>
+        </p:spPr>
+        <p:txBody>
+          <a:bodyPr wrap="square" lIns="0" tIns="0" rIns="0" bIns="0" rtlCol="0" anchor="t"/>
+          <a:lstStyle/>
+          <a:p>
+            <a:pPr indent="0" marL="0">
+              <a:lnSpc>
+                <a:spcPct val="118000"/>
+              </a:lnSpc>
+              <a:buNone/>
+            </a:pPr>
+            <a:r>
+              <a:rPr lang="en-US" sz="2800" b="1" dirty="0">
+                <a:solidFill>
+                  <a:srgbClr val="F4F5F6"/>
+                </a:solidFill>
+                <a:latin typeface="Roboto" pitchFamily="34" charset="0"/>
+                <a:ea typeface="Roboto" pitchFamily="34" charset="-122"/>
+                <a:cs typeface="Roboto" pitchFamily="34" charset="-120"/>
+              </a:rPr>
+              <a:t>Nenhuma delas gritou.</a:t>
+            </a:r>
+            <a:endParaRPr lang="en-US" sz="2800" dirty="0"/>
+          </a:p>
+        </p:txBody>
+      </p:sp>
+      <p:pic>
+        <p:nvPicPr>
+          <p:cNvPr id="9" name="Image 3" descr="art\seta.png">    </p:cNvPr>
+          <p:cNvPicPr>
+            <a:picLocks noChangeAspect="1"/>
+          </p:cNvPicPr>
+          <p:nvPr/>
+        </p:nvPicPr>
+        <p:blipFill>
+          <a:blip r:embed="rId4"/>
+          <a:stretch>
+            <a:fillRect/>
+          </a:stretch>
+        </p:blipFill>
+        <p:spPr>
+          <a:xfrm>
+            <a:off x="2423160" y="8426196"/>
+            <a:ext cx="475488" cy="411480"/>
+          </a:xfrm>
+          <a:prstGeom prst="rect">
+            <a:avLst/>
+          </a:prstGeom>
+        </p:spPr>
+      </p:pic>
+      <p:sp>
+        <p:nvSpPr>
+          <p:cNvPr id="10" name="Text 4"/>
+          <p:cNvSpPr txBox="1"/>
+          <p:nvPr/>
+        </p:nvSpPr>
+        <p:spPr>
+          <a:xfrm>
+            <a:off x="3337560" y="8298180"/>
+            <a:ext cx="17922240" cy="548640"/>
+          </a:xfrm>
+          <a:prstGeom prst="rect">
+            <a:avLst/>
+          </a:prstGeom>
+          <a:noFill/>
+          <a:ln/>
+        </p:spPr>
+        <p:txBody>
+          <a:bodyPr wrap="square" lIns="0" tIns="0" rIns="0" bIns="0" rtlCol="0" anchor="t"/>
+          <a:lstStyle/>
+          <a:p>
+            <a:pPr indent="0" marL="0">
+              <a:lnSpc>
+                <a:spcPct val="118000"/>
+              </a:lnSpc>
+              <a:buNone/>
+            </a:pPr>
+            <a:r>
+              <a:rPr lang="en-US" sz="2800" dirty="0">
+                <a:solidFill>
+                  <a:srgbClr val="A7A9B4"/>
+                </a:solidFill>
+                <a:latin typeface="Roboto" pitchFamily="34" charset="0"/>
+                <a:ea typeface="Roboto" pitchFamily="34" charset="-122"/>
+                <a:cs typeface="Roboto" pitchFamily="34" charset="-120"/>
+              </a:rPr>
+              <a:t>Nenhum usuário reclamou de nenhuma — a última, nem eu tinha certeza se o erro era meu.</a:t>
+            </a:r>
+            <a:endParaRPr lang="en-US" sz="2800" dirty="0"/>
+          </a:p>
+        </p:txBody>
+      </p:sp>
+      <p:pic>
+        <p:nvPicPr>
+          <p:cNvPr id="11" name="Image 4" descr="art\seta.png">    </p:cNvPr>
+          <p:cNvPicPr>
+            <a:picLocks noChangeAspect="1"/>
+          </p:cNvPicPr>
+          <p:nvPr/>
+        </p:nvPicPr>
+        <p:blipFill>
+          <a:blip r:embed="rId5"/>
+          <a:stretch>
+            <a:fillRect/>
+          </a:stretch>
+        </p:blipFill>
+        <p:spPr>
+          <a:xfrm>
+            <a:off x="2423160" y="9980676"/>
+            <a:ext cx="475488" cy="411480"/>
+          </a:xfrm>
+          <a:prstGeom prst="rect">
+            <a:avLst/>
+          </a:prstGeom>
+        </p:spPr>
+      </p:pic>
+      <p:sp>
+        <p:nvSpPr>
+          <p:cNvPr id="12" name="Text 5"/>
+          <p:cNvSpPr txBox="1"/>
+          <p:nvPr/>
+        </p:nvSpPr>
+        <p:spPr>
+          <a:xfrm>
+            <a:off x="3337560" y="9852660"/>
+            <a:ext cx="17922240" cy="548640"/>
+          </a:xfrm>
+          <a:prstGeom prst="rect">
+            <a:avLst/>
+          </a:prstGeom>
+          <a:noFill/>
+          <a:ln/>
+        </p:spPr>
+        <p:txBody>
+          <a:bodyPr wrap="square" lIns="0" tIns="0" rIns="0" bIns="0" rtlCol="0" anchor="t"/>
+          <a:lstStyle/>
+          <a:p>
+            <a:pPr indent="0" marL="0">
+              <a:lnSpc>
+                <a:spcPct val="118000"/>
+              </a:lnSpc>
+              <a:buNone/>
+            </a:pPr>
+            <a:r>
+              <a:rPr lang="en-US" sz="2800" dirty="0">
+                <a:solidFill>
+                  <a:srgbClr val="A7A9B4"/>
+                </a:solidFill>
+                <a:latin typeface="Roboto" pitchFamily="34" charset="0"/>
+                <a:ea typeface="Roboto" pitchFamily="34" charset="-122"/>
+                <a:cs typeface="Roboto" pitchFamily="34" charset="-120"/>
+              </a:rPr>
+              <a:t>Cada uma precisou de alguém olhando o dado certo, com a pergunta certa — e esse alguém é você.</a:t>
+            </a:r>
+            <a:endParaRPr lang="en-US" sz="2800" dirty="0"/>
+          </a:p>
+        </p:txBody>
+      </p:sp>
+      <p:sp>
+        <p:nvSpPr>
+          <p:cNvPr id="13" name="Text 6"/>
+          <p:cNvSpPr txBox="1"/>
+          <p:nvPr/>
+        </p:nvSpPr>
+        <p:spPr>
+          <a:xfrm>
+            <a:off x="2423160" y="12755880"/>
+            <a:ext cx="19540728" cy="457200"/>
+          </a:xfrm>
+          <a:prstGeom prst="rect">
+            <a:avLst/>
+          </a:prstGeom>
+          <a:noFill/>
+          <a:ln/>
+        </p:spPr>
+        <p:txBody>
+          <a:bodyPr wrap="square" lIns="0" tIns="0" rIns="0" bIns="0" rtlCol="0" anchor="ctr"/>
+          <a:lstStyle/>
+          <a:p>
+            <a:pPr indent="0" marL="0">
+              <a:buNone/>
+            </a:pPr>
+            <a:r>
+              <a:rPr lang="en-US" sz="1500" dirty="0">
+                <a:solidFill>
+                  <a:srgbClr val="A7A9B4">
+                    <a:alpha val="65000"/>
+                  </a:srgbClr>
+                </a:solidFill>
+                <a:latin typeface="Roboto" pitchFamily="34" charset="0"/>
+                <a:ea typeface="Roboto" pitchFamily="34" charset="-122"/>
+                <a:cs typeface="Roboto" pitchFamily="34" charset="-120"/>
+              </a:rPr>
+              <a:t>Aula 3 — Observabilidade: monitorando em produção — Evals, observabilidade e conformidade</a:t>
+            </a:r>
+            <a:endParaRPr lang="en-US" sz="1500" dirty="0"/>
+          </a:p>
+        </p:txBody>
+      </p:sp>
+    </p:spTree>
+  </p:cSld>
+  <p:clrMapOvr>
+    <a:masterClrMapping/>
+  </p:clrMapOvr>
+</p:sld>
+</file>
+
+<file path=ppt/slides/slide19.xml><?xml version="1.0" encoding="utf-8"?>
+<p:sld xmlns:a="http://schemas.openxmlformats.org/drawingml/2006/main" xmlns:r="http://schemas.openxmlformats.org/officeDocument/2006/relationships" xmlns:p="http://schemas.openxmlformats.org/presentationml/2006/main">
+  <p:cSld name="Slide 19">
     <p:bg>
       <p:bgPr>
         <a:solidFill>
@@ -7594,492 +8169,6 @@
               <a:t>3.5 O que aprendemos?</a:t>
             </a:r>
             <a:endParaRPr lang="en-US" sz="9600" dirty="0"/>
-          </a:p>
-        </p:txBody>
-      </p:sp>
-    </p:spTree>
-  </p:cSld>
-  <p:clrMapOvr>
-    <a:masterClrMapping/>
-  </p:clrMapOvr>
-</p:sld>
-</file>
-
-<file path=ppt/slides/slide19.xml><?xml version="1.0" encoding="utf-8"?>
-<p:sld xmlns:a="http://schemas.openxmlformats.org/drawingml/2006/main" xmlns:r="http://schemas.openxmlformats.org/officeDocument/2006/relationships" xmlns:p="http://schemas.openxmlformats.org/presentationml/2006/main">
-  <p:cSld name="Slide 19">
-    <p:bg>
-      <p:bgPr>
-        <a:solidFill>
-          <a:srgbClr val="0C0C0E"/>
-        </a:solidFill>
-      </p:bgPr>
-    </p:bg>
-    <p:spTree>
-      <p:nvGrpSpPr>
-        <p:cNvPr id="1" name=""/>
-        <p:cNvGrpSpPr/>
-        <p:nvPr/>
-      </p:nvGrpSpPr>
-      <p:grpSpPr>
-        <a:xfrm>
-          <a:off x="0" y="0"/>
-          <a:ext cx="0" cy="0"/>
-          <a:chOff x="0" y="0"/>
-          <a:chExt cx="0" cy="0"/>
-        </a:xfrm>
-      </p:grpSpPr>
-      <p:pic>
-        <p:nvPicPr>
-          <p:cNvPr id="2" name="Image 0" descr="art\malha.png">    </p:cNvPr>
-          <p:cNvPicPr>
-            <a:picLocks noChangeAspect="1"/>
-          </p:cNvPicPr>
-          <p:nvPr/>
-        </p:nvPicPr>
-        <p:blipFill>
-          <a:blip r:embed="rId1"/>
-          <a:stretch>
-            <a:fillRect/>
-          </a:stretch>
-        </p:blipFill>
-        <p:spPr>
-          <a:xfrm>
-            <a:off x="0" y="0"/>
-            <a:ext cx="24387048" cy="13716000"/>
-          </a:xfrm>
-          <a:prstGeom prst="rect">
-            <a:avLst/>
-          </a:prstGeom>
-        </p:spPr>
-      </p:pic>
-      <p:pic>
-        <p:nvPicPr>
-          <p:cNvPr id="3" name="Image 1" descr="art\logo.png">    </p:cNvPr>
-          <p:cNvPicPr>
-            <a:picLocks noChangeAspect="1"/>
-          </p:cNvPicPr>
-          <p:nvPr/>
-        </p:nvPicPr>
-        <p:blipFill>
-          <a:blip r:embed="rId2"/>
-          <a:stretch>
-            <a:fillRect/>
-          </a:stretch>
-        </p:blipFill>
-        <p:spPr>
-          <a:xfrm>
-            <a:off x="23436072" y="402336"/>
-            <a:ext cx="475488" cy="594360"/>
-          </a:xfrm>
-          <a:prstGeom prst="rect">
-            <a:avLst/>
-          </a:prstGeom>
-        </p:spPr>
-      </p:pic>
-      <p:sp>
-        <p:nvSpPr>
-          <p:cNvPr id="4" name="Text 0"/>
-          <p:cNvSpPr txBox="1"/>
-          <p:nvPr/>
-        </p:nvSpPr>
-        <p:spPr>
-          <a:xfrm>
-            <a:off x="2423160" y="1051560"/>
-            <a:ext cx="19540728" cy="594360"/>
-          </a:xfrm>
-          <a:prstGeom prst="rect">
-            <a:avLst/>
-          </a:prstGeom>
-          <a:noFill/>
-          <a:ln/>
-        </p:spPr>
-        <p:txBody>
-          <a:bodyPr wrap="square" lIns="0" tIns="0" rIns="0" bIns="0" rtlCol="0" anchor="ctr"/>
-          <a:lstStyle/>
-          <a:p>
-            <a:pPr indent="0" marL="0">
-              <a:buNone/>
-            </a:pPr>
-            <a:r>
-              <a:rPr lang="en-US" sz="2100" b="1" spc="250" kern="0" dirty="0">
-                <a:solidFill>
-                  <a:srgbClr val="1F53E5"/>
-                </a:solidFill>
-                <a:latin typeface="Encode Sans" pitchFamily="34" charset="0"/>
-                <a:ea typeface="Encode Sans" pitchFamily="34" charset="-122"/>
-                <a:cs typeface="Encode Sans" pitchFamily="34" charset="-120"/>
-              </a:rPr>
-              <a:t>FECHAMENTO DA AULA</a:t>
-            </a:r>
-            <a:endParaRPr lang="en-US" sz="2100" dirty="0"/>
-          </a:p>
-        </p:txBody>
-      </p:sp>
-      <p:sp>
-        <p:nvSpPr>
-          <p:cNvPr id="5" name="Text 1"/>
-          <p:cNvSpPr txBox="1"/>
-          <p:nvPr/>
-        </p:nvSpPr>
-        <p:spPr>
-          <a:xfrm>
-            <a:off x="2423160" y="1783080"/>
-            <a:ext cx="19568160" cy="2377440"/>
-          </a:xfrm>
-          <a:prstGeom prst="rect">
-            <a:avLst/>
-          </a:prstGeom>
-          <a:noFill/>
-          <a:ln/>
-        </p:spPr>
-        <p:txBody>
-          <a:bodyPr wrap="square" lIns="0" tIns="0" rIns="0" bIns="0" rtlCol="0" anchor="t"/>
-          <a:lstStyle/>
-          <a:p>
-            <a:pPr indent="0" marL="0">
-              <a:lnSpc>
-                <a:spcPct val="105000"/>
-              </a:lnSpc>
-              <a:buNone/>
-            </a:pPr>
-            <a:r>
-              <a:rPr lang="en-US" sz="6600" dirty="0">
-                <a:solidFill>
-                  <a:srgbClr val="BDBFC7"/>
-                </a:solidFill>
-                <a:latin typeface="Encode Sans" pitchFamily="34" charset="0"/>
-                <a:ea typeface="Encode Sans" pitchFamily="34" charset="-122"/>
-                <a:cs typeface="Encode Sans" pitchFamily="34" charset="-120"/>
-              </a:rPr>
-              <a:t>O que aprendemos</a:t>
-            </a:r>
-            <a:endParaRPr lang="en-US" sz="6600" dirty="0"/>
-          </a:p>
-        </p:txBody>
-      </p:sp>
-      <p:sp>
-        <p:nvSpPr>
-          <p:cNvPr id="6" name="Shape 2"/>
-          <p:cNvSpPr/>
-          <p:nvPr/>
-        </p:nvSpPr>
-        <p:spPr>
-          <a:xfrm>
-            <a:off x="2423160" y="4526280"/>
-            <a:ext cx="2011680" cy="68580"/>
-          </a:xfrm>
-          <a:prstGeom prst="rect">
-            <a:avLst/>
-          </a:prstGeom>
-          <a:solidFill>
-            <a:srgbClr val="1F53E5"/>
-          </a:solidFill>
-          <a:ln/>
-        </p:spPr>
-      </p:sp>
-      <p:pic>
-        <p:nvPicPr>
-          <p:cNvPr id="7" name="Image 2" descr="art\seta.png">    </p:cNvPr>
-          <p:cNvPicPr>
-            <a:picLocks noChangeAspect="1"/>
-          </p:cNvPicPr>
-          <p:nvPr/>
-        </p:nvPicPr>
-        <p:blipFill>
-          <a:blip r:embed="rId3"/>
-          <a:stretch>
-            <a:fillRect/>
-          </a:stretch>
-        </p:blipFill>
-        <p:spPr>
-          <a:xfrm>
-            <a:off x="2423160" y="6094476"/>
-            <a:ext cx="475488" cy="411480"/>
-          </a:xfrm>
-          <a:prstGeom prst="rect">
-            <a:avLst/>
-          </a:prstGeom>
-        </p:spPr>
-      </p:pic>
-      <p:sp>
-        <p:nvSpPr>
-          <p:cNvPr id="8" name="Text 3"/>
-          <p:cNvSpPr txBox="1"/>
-          <p:nvPr/>
-        </p:nvSpPr>
-        <p:spPr>
-          <a:xfrm>
-            <a:off x="3337560" y="5966460"/>
-            <a:ext cx="17922240" cy="548640"/>
-          </a:xfrm>
-          <a:prstGeom prst="rect">
-            <a:avLst/>
-          </a:prstGeom>
-          <a:noFill/>
-          <a:ln/>
-        </p:spPr>
-        <p:txBody>
-          <a:bodyPr wrap="square" lIns="0" tIns="0" rIns="0" bIns="0" rtlCol="0" anchor="t"/>
-          <a:lstStyle/>
-          <a:p>
-            <a:pPr indent="0" marL="0">
-              <a:lnSpc>
-                <a:spcPct val="118000"/>
-              </a:lnSpc>
-              <a:buNone/>
-            </a:pPr>
-            <a:r>
-              <a:rPr lang="en-US" sz="2800" dirty="0">
-                <a:solidFill>
-                  <a:srgbClr val="A7A9B4"/>
-                </a:solidFill>
-                <a:latin typeface="Roboto" pitchFamily="34" charset="0"/>
-                <a:ea typeface="Roboto" pitchFamily="34" charset="-122"/>
-                <a:cs typeface="Roboto" pitchFamily="34" charset="-120"/>
-              </a:rPr>
-              <a:t>Observabilidade é reconstruir a causa, não só registrar o evento.</a:t>
-            </a:r>
-            <a:endParaRPr lang="en-US" sz="2800" dirty="0"/>
-          </a:p>
-        </p:txBody>
-      </p:sp>
-      <p:pic>
-        <p:nvPicPr>
-          <p:cNvPr id="9" name="Image 3" descr="art\seta.png">    </p:cNvPr>
-          <p:cNvPicPr>
-            <a:picLocks noChangeAspect="1"/>
-          </p:cNvPicPr>
-          <p:nvPr/>
-        </p:nvPicPr>
-        <p:blipFill>
-          <a:blip r:embed="rId4"/>
-          <a:stretch>
-            <a:fillRect/>
-          </a:stretch>
-        </p:blipFill>
-        <p:spPr>
-          <a:xfrm>
-            <a:off x="2423160" y="7648956"/>
-            <a:ext cx="475488" cy="411480"/>
-          </a:xfrm>
-          <a:prstGeom prst="rect">
-            <a:avLst/>
-          </a:prstGeom>
-        </p:spPr>
-      </p:pic>
-      <p:sp>
-        <p:nvSpPr>
-          <p:cNvPr id="10" name="Text 4"/>
-          <p:cNvSpPr txBox="1"/>
-          <p:nvPr/>
-        </p:nvSpPr>
-        <p:spPr>
-          <a:xfrm>
-            <a:off x="3337560" y="7520940"/>
-            <a:ext cx="17922240" cy="548640"/>
-          </a:xfrm>
-          <a:prstGeom prst="rect">
-            <a:avLst/>
-          </a:prstGeom>
-          <a:noFill/>
-          <a:ln/>
-        </p:spPr>
-        <p:txBody>
-          <a:bodyPr wrap="square" lIns="0" tIns="0" rIns="0" bIns="0" rtlCol="0" anchor="t"/>
-          <a:lstStyle/>
-          <a:p>
-            <a:pPr indent="0" marL="0">
-              <a:lnSpc>
-                <a:spcPct val="118000"/>
-              </a:lnSpc>
-              <a:buNone/>
-            </a:pPr>
-            <a:r>
-              <a:rPr lang="en-US" sz="2800" dirty="0">
-                <a:solidFill>
-                  <a:srgbClr val="A7A9B4"/>
-                </a:solidFill>
-                <a:latin typeface="Roboto" pitchFamily="34" charset="0"/>
-                <a:ea typeface="Roboto" pitchFamily="34" charset="-122"/>
-                <a:cs typeface="Roboto" pitchFamily="34" charset="-120"/>
-              </a:rPr>
-              <a:t>Interação, passo e nota são o vocabulário que você precisa para navegar o painel sozinha.</a:t>
-            </a:r>
-            <a:endParaRPr lang="en-US" sz="2800" dirty="0"/>
-          </a:p>
-        </p:txBody>
-      </p:sp>
-      <p:pic>
-        <p:nvPicPr>
-          <p:cNvPr id="11" name="Image 4" descr="art\seta.png">    </p:cNvPr>
-          <p:cNvPicPr>
-            <a:picLocks noChangeAspect="1"/>
-          </p:cNvPicPr>
-          <p:nvPr/>
-        </p:nvPicPr>
-        <p:blipFill>
-          <a:blip r:embed="rId5"/>
-          <a:stretch>
-            <a:fillRect/>
-          </a:stretch>
-        </p:blipFill>
-        <p:spPr>
-          <a:xfrm>
-            <a:off x="2423160" y="9203436"/>
-            <a:ext cx="475488" cy="411480"/>
-          </a:xfrm>
-          <a:prstGeom prst="rect">
-            <a:avLst/>
-          </a:prstGeom>
-        </p:spPr>
-      </p:pic>
-      <p:sp>
-        <p:nvSpPr>
-          <p:cNvPr id="12" name="Text 5"/>
-          <p:cNvSpPr txBox="1"/>
-          <p:nvPr/>
-        </p:nvSpPr>
-        <p:spPr>
-          <a:xfrm>
-            <a:off x="3337560" y="9075420"/>
-            <a:ext cx="17922240" cy="548640"/>
-          </a:xfrm>
-          <a:prstGeom prst="rect">
-            <a:avLst/>
-          </a:prstGeom>
-          <a:noFill/>
-          <a:ln/>
-        </p:spPr>
-        <p:txBody>
-          <a:bodyPr wrap="square" lIns="0" tIns="0" rIns="0" bIns="0" rtlCol="0" anchor="t"/>
-          <a:lstStyle/>
-          <a:p>
-            <a:pPr indent="0" marL="0">
-              <a:lnSpc>
-                <a:spcPct val="118000"/>
-              </a:lnSpc>
-              <a:buNone/>
-            </a:pPr>
-            <a:r>
-              <a:rPr lang="en-US" sz="2800" b="1" dirty="0">
-                <a:solidFill>
-                  <a:srgbClr val="F4F5F6"/>
-                </a:solidFill>
-                <a:latin typeface="Roboto" pitchFamily="34" charset="0"/>
-                <a:ea typeface="Roboto" pitchFamily="34" charset="-122"/>
-                <a:cs typeface="Roboto" pitchFamily="34" charset="-120"/>
-              </a:rPr>
-              <a:t>Com dado real dá para ver para onde o dinheiro está indo — e onde trocar de modelo compensa.</a:t>
-            </a:r>
-            <a:endParaRPr lang="en-US" sz="2800" dirty="0"/>
-          </a:p>
-        </p:txBody>
-      </p:sp>
-      <p:pic>
-        <p:nvPicPr>
-          <p:cNvPr id="13" name="Image 5" descr="art\seta.png">    </p:cNvPr>
-          <p:cNvPicPr>
-            <a:picLocks noChangeAspect="1"/>
-          </p:cNvPicPr>
-          <p:nvPr/>
-        </p:nvPicPr>
-        <p:blipFill>
-          <a:blip r:embed="rId6"/>
-          <a:stretch>
-            <a:fillRect/>
-          </a:stretch>
-        </p:blipFill>
-        <p:spPr>
-          <a:xfrm>
-            <a:off x="2423160" y="10757916"/>
-            <a:ext cx="475488" cy="411480"/>
-          </a:xfrm>
-          <a:prstGeom prst="rect">
-            <a:avLst/>
-          </a:prstGeom>
-        </p:spPr>
-      </p:pic>
-      <p:sp>
-        <p:nvSpPr>
-          <p:cNvPr id="14" name="Text 6"/>
-          <p:cNvSpPr txBox="1"/>
-          <p:nvPr/>
-        </p:nvSpPr>
-        <p:spPr>
-          <a:xfrm>
-            <a:off x="3337560" y="10629900"/>
-            <a:ext cx="17922240" cy="548640"/>
-          </a:xfrm>
-          <a:prstGeom prst="rect">
-            <a:avLst/>
-          </a:prstGeom>
-          <a:noFill/>
-          <a:ln/>
-        </p:spPr>
-        <p:txBody>
-          <a:bodyPr wrap="square" lIns="0" tIns="0" rIns="0" bIns="0" rtlCol="0" anchor="t"/>
-          <a:lstStyle/>
-          <a:p>
-            <a:pPr indent="0" marL="0">
-              <a:lnSpc>
-                <a:spcPct val="118000"/>
-              </a:lnSpc>
-              <a:buNone/>
-            </a:pPr>
-            <a:r>
-              <a:rPr lang="en-US" sz="2800" dirty="0">
-                <a:solidFill>
-                  <a:srgbClr val="A7A9B4"/>
-                </a:solidFill>
-                <a:latin typeface="Roboto" pitchFamily="34" charset="0"/>
-                <a:ea typeface="Roboto" pitchFamily="34" charset="-122"/>
-                <a:cs typeface="Roboto" pitchFamily="34" charset="-120"/>
-              </a:rPr>
-              <a:t>Quatro falhas documentadas, nenhuma descoberta por reclamação de usuário.</a:t>
-            </a:r>
-            <a:endParaRPr lang="en-US" sz="2800" dirty="0"/>
-          </a:p>
-        </p:txBody>
-      </p:sp>
-      <p:sp>
-        <p:nvSpPr>
-          <p:cNvPr id="15" name="Text 7"/>
-          <p:cNvSpPr txBox="1"/>
-          <p:nvPr/>
-        </p:nvSpPr>
-        <p:spPr>
-          <a:xfrm>
-            <a:off x="2423160" y="12755880"/>
-            <a:ext cx="19540728" cy="457200"/>
-          </a:xfrm>
-          <a:prstGeom prst="rect">
-            <a:avLst/>
-          </a:prstGeom>
-          <a:noFill/>
-          <a:ln/>
-        </p:spPr>
-        <p:txBody>
-          <a:bodyPr wrap="square" lIns="0" tIns="0" rIns="0" bIns="0" rtlCol="0" anchor="ctr"/>
-          <a:lstStyle/>
-          <a:p>
-            <a:pPr indent="0" marL="0">
-              <a:buNone/>
-            </a:pPr>
-            <a:r>
-              <a:rPr lang="en-US" sz="1500" dirty="0">
-                <a:solidFill>
-                  <a:srgbClr val="A7A9B4">
-                    <a:alpha val="65000"/>
-                  </a:srgbClr>
-                </a:solidFill>
-                <a:latin typeface="Roboto" pitchFamily="34" charset="0"/>
-                <a:ea typeface="Roboto" pitchFamily="34" charset="-122"/>
-                <a:cs typeface="Roboto" pitchFamily="34" charset="-120"/>
-              </a:rPr>
-              <a:t>Aula 3 — Observabilidade: monitorando em produção — Evals, observabilidade e conformidade</a:t>
-            </a:r>
-            <a:endParaRPr lang="en-US" sz="1500" dirty="0"/>
           </a:p>
         </p:txBody>
       </p:sp>
@@ -8192,6 +8281,492 @@
 <file path=ppt/slides/slide20.xml><?xml version="1.0" encoding="utf-8"?>
 <p:sld xmlns:a="http://schemas.openxmlformats.org/drawingml/2006/main" xmlns:r="http://schemas.openxmlformats.org/officeDocument/2006/relationships" xmlns:p="http://schemas.openxmlformats.org/presentationml/2006/main">
   <p:cSld name="Slide 20">
+    <p:bg>
+      <p:bgPr>
+        <a:solidFill>
+          <a:srgbClr val="0C0C0E"/>
+        </a:solidFill>
+      </p:bgPr>
+    </p:bg>
+    <p:spTree>
+      <p:nvGrpSpPr>
+        <p:cNvPr id="1" name=""/>
+        <p:cNvGrpSpPr/>
+        <p:nvPr/>
+      </p:nvGrpSpPr>
+      <p:grpSpPr>
+        <a:xfrm>
+          <a:off x="0" y="0"/>
+          <a:ext cx="0" cy="0"/>
+          <a:chOff x="0" y="0"/>
+          <a:chExt cx="0" cy="0"/>
+        </a:xfrm>
+      </p:grpSpPr>
+      <p:pic>
+        <p:nvPicPr>
+          <p:cNvPr id="2" name="Image 0" descr="art\malha.png">    </p:cNvPr>
+          <p:cNvPicPr>
+            <a:picLocks noChangeAspect="1"/>
+          </p:cNvPicPr>
+          <p:nvPr/>
+        </p:nvPicPr>
+        <p:blipFill>
+          <a:blip r:embed="rId1"/>
+          <a:stretch>
+            <a:fillRect/>
+          </a:stretch>
+        </p:blipFill>
+        <p:spPr>
+          <a:xfrm>
+            <a:off x="0" y="0"/>
+            <a:ext cx="24387048" cy="13716000"/>
+          </a:xfrm>
+          <a:prstGeom prst="rect">
+            <a:avLst/>
+          </a:prstGeom>
+        </p:spPr>
+      </p:pic>
+      <p:pic>
+        <p:nvPicPr>
+          <p:cNvPr id="3" name="Image 1" descr="art\logo.png">    </p:cNvPr>
+          <p:cNvPicPr>
+            <a:picLocks noChangeAspect="1"/>
+          </p:cNvPicPr>
+          <p:nvPr/>
+        </p:nvPicPr>
+        <p:blipFill>
+          <a:blip r:embed="rId2"/>
+          <a:stretch>
+            <a:fillRect/>
+          </a:stretch>
+        </p:blipFill>
+        <p:spPr>
+          <a:xfrm>
+            <a:off x="23436072" y="402336"/>
+            <a:ext cx="475488" cy="594360"/>
+          </a:xfrm>
+          <a:prstGeom prst="rect">
+            <a:avLst/>
+          </a:prstGeom>
+        </p:spPr>
+      </p:pic>
+      <p:sp>
+        <p:nvSpPr>
+          <p:cNvPr id="4" name="Text 0"/>
+          <p:cNvSpPr txBox="1"/>
+          <p:nvPr/>
+        </p:nvSpPr>
+        <p:spPr>
+          <a:xfrm>
+            <a:off x="2423160" y="1051560"/>
+            <a:ext cx="19540728" cy="594360"/>
+          </a:xfrm>
+          <a:prstGeom prst="rect">
+            <a:avLst/>
+          </a:prstGeom>
+          <a:noFill/>
+          <a:ln/>
+        </p:spPr>
+        <p:txBody>
+          <a:bodyPr wrap="square" lIns="0" tIns="0" rIns="0" bIns="0" rtlCol="0" anchor="ctr"/>
+          <a:lstStyle/>
+          <a:p>
+            <a:pPr indent="0" marL="0">
+              <a:buNone/>
+            </a:pPr>
+            <a:r>
+              <a:rPr lang="en-US" sz="2100" b="1" spc="250" kern="0" dirty="0">
+                <a:solidFill>
+                  <a:srgbClr val="1F53E5"/>
+                </a:solidFill>
+                <a:latin typeface="Encode Sans" pitchFamily="34" charset="0"/>
+                <a:ea typeface="Encode Sans" pitchFamily="34" charset="-122"/>
+                <a:cs typeface="Encode Sans" pitchFamily="34" charset="-120"/>
+              </a:rPr>
+              <a:t>FECHAMENTO DA AULA</a:t>
+            </a:r>
+            <a:endParaRPr lang="en-US" sz="2100" dirty="0"/>
+          </a:p>
+        </p:txBody>
+      </p:sp>
+      <p:sp>
+        <p:nvSpPr>
+          <p:cNvPr id="5" name="Text 1"/>
+          <p:cNvSpPr txBox="1"/>
+          <p:nvPr/>
+        </p:nvSpPr>
+        <p:spPr>
+          <a:xfrm>
+            <a:off x="2423160" y="1783080"/>
+            <a:ext cx="19568160" cy="2377440"/>
+          </a:xfrm>
+          <a:prstGeom prst="rect">
+            <a:avLst/>
+          </a:prstGeom>
+          <a:noFill/>
+          <a:ln/>
+        </p:spPr>
+        <p:txBody>
+          <a:bodyPr wrap="square" lIns="0" tIns="0" rIns="0" bIns="0" rtlCol="0" anchor="t"/>
+          <a:lstStyle/>
+          <a:p>
+            <a:pPr indent="0" marL="0">
+              <a:lnSpc>
+                <a:spcPct val="105000"/>
+              </a:lnSpc>
+              <a:buNone/>
+            </a:pPr>
+            <a:r>
+              <a:rPr lang="en-US" sz="6600" dirty="0">
+                <a:solidFill>
+                  <a:srgbClr val="BDBFC7"/>
+                </a:solidFill>
+                <a:latin typeface="Encode Sans" pitchFamily="34" charset="0"/>
+                <a:ea typeface="Encode Sans" pitchFamily="34" charset="-122"/>
+                <a:cs typeface="Encode Sans" pitchFamily="34" charset="-120"/>
+              </a:rPr>
+              <a:t>O que aprendemos</a:t>
+            </a:r>
+            <a:endParaRPr lang="en-US" sz="6600" dirty="0"/>
+          </a:p>
+        </p:txBody>
+      </p:sp>
+      <p:sp>
+        <p:nvSpPr>
+          <p:cNvPr id="6" name="Shape 2"/>
+          <p:cNvSpPr/>
+          <p:nvPr/>
+        </p:nvSpPr>
+        <p:spPr>
+          <a:xfrm>
+            <a:off x="2423160" y="4526280"/>
+            <a:ext cx="2011680" cy="68580"/>
+          </a:xfrm>
+          <a:prstGeom prst="rect">
+            <a:avLst/>
+          </a:prstGeom>
+          <a:solidFill>
+            <a:srgbClr val="1F53E5"/>
+          </a:solidFill>
+          <a:ln/>
+        </p:spPr>
+      </p:sp>
+      <p:pic>
+        <p:nvPicPr>
+          <p:cNvPr id="7" name="Image 2" descr="art\seta.png">    </p:cNvPr>
+          <p:cNvPicPr>
+            <a:picLocks noChangeAspect="1"/>
+          </p:cNvPicPr>
+          <p:nvPr/>
+        </p:nvPicPr>
+        <p:blipFill>
+          <a:blip r:embed="rId3"/>
+          <a:stretch>
+            <a:fillRect/>
+          </a:stretch>
+        </p:blipFill>
+        <p:spPr>
+          <a:xfrm>
+            <a:off x="2423160" y="6094476"/>
+            <a:ext cx="475488" cy="411480"/>
+          </a:xfrm>
+          <a:prstGeom prst="rect">
+            <a:avLst/>
+          </a:prstGeom>
+        </p:spPr>
+      </p:pic>
+      <p:sp>
+        <p:nvSpPr>
+          <p:cNvPr id="8" name="Text 3"/>
+          <p:cNvSpPr txBox="1"/>
+          <p:nvPr/>
+        </p:nvSpPr>
+        <p:spPr>
+          <a:xfrm>
+            <a:off x="3337560" y="5966460"/>
+            <a:ext cx="17922240" cy="548640"/>
+          </a:xfrm>
+          <a:prstGeom prst="rect">
+            <a:avLst/>
+          </a:prstGeom>
+          <a:noFill/>
+          <a:ln/>
+        </p:spPr>
+        <p:txBody>
+          <a:bodyPr wrap="square" lIns="0" tIns="0" rIns="0" bIns="0" rtlCol="0" anchor="t"/>
+          <a:lstStyle/>
+          <a:p>
+            <a:pPr indent="0" marL="0">
+              <a:lnSpc>
+                <a:spcPct val="118000"/>
+              </a:lnSpc>
+              <a:buNone/>
+            </a:pPr>
+            <a:r>
+              <a:rPr lang="en-US" sz="2800" dirty="0">
+                <a:solidFill>
+                  <a:srgbClr val="A7A9B4"/>
+                </a:solidFill>
+                <a:latin typeface="Roboto" pitchFamily="34" charset="0"/>
+                <a:ea typeface="Roboto" pitchFamily="34" charset="-122"/>
+                <a:cs typeface="Roboto" pitchFamily="34" charset="-120"/>
+              </a:rPr>
+              <a:t>Observabilidade é reconstruir a causa, não só registrar o evento.</a:t>
+            </a:r>
+            <a:endParaRPr lang="en-US" sz="2800" dirty="0"/>
+          </a:p>
+        </p:txBody>
+      </p:sp>
+      <p:pic>
+        <p:nvPicPr>
+          <p:cNvPr id="9" name="Image 3" descr="art\seta.png">    </p:cNvPr>
+          <p:cNvPicPr>
+            <a:picLocks noChangeAspect="1"/>
+          </p:cNvPicPr>
+          <p:nvPr/>
+        </p:nvPicPr>
+        <p:blipFill>
+          <a:blip r:embed="rId4"/>
+          <a:stretch>
+            <a:fillRect/>
+          </a:stretch>
+        </p:blipFill>
+        <p:spPr>
+          <a:xfrm>
+            <a:off x="2423160" y="7648956"/>
+            <a:ext cx="475488" cy="411480"/>
+          </a:xfrm>
+          <a:prstGeom prst="rect">
+            <a:avLst/>
+          </a:prstGeom>
+        </p:spPr>
+      </p:pic>
+      <p:sp>
+        <p:nvSpPr>
+          <p:cNvPr id="10" name="Text 4"/>
+          <p:cNvSpPr txBox="1"/>
+          <p:nvPr/>
+        </p:nvSpPr>
+        <p:spPr>
+          <a:xfrm>
+            <a:off x="3337560" y="7520940"/>
+            <a:ext cx="17922240" cy="548640"/>
+          </a:xfrm>
+          <a:prstGeom prst="rect">
+            <a:avLst/>
+          </a:prstGeom>
+          <a:noFill/>
+          <a:ln/>
+        </p:spPr>
+        <p:txBody>
+          <a:bodyPr wrap="square" lIns="0" tIns="0" rIns="0" bIns="0" rtlCol="0" anchor="t"/>
+          <a:lstStyle/>
+          <a:p>
+            <a:pPr indent="0" marL="0">
+              <a:lnSpc>
+                <a:spcPct val="118000"/>
+              </a:lnSpc>
+              <a:buNone/>
+            </a:pPr>
+            <a:r>
+              <a:rPr lang="en-US" sz="2800" dirty="0">
+                <a:solidFill>
+                  <a:srgbClr val="A7A9B4"/>
+                </a:solidFill>
+                <a:latin typeface="Roboto" pitchFamily="34" charset="0"/>
+                <a:ea typeface="Roboto" pitchFamily="34" charset="-122"/>
+                <a:cs typeface="Roboto" pitchFamily="34" charset="-120"/>
+              </a:rPr>
+              <a:t>Interação, passo e nota são o vocabulário que você precisa para navegar o painel sozinha.</a:t>
+            </a:r>
+            <a:endParaRPr lang="en-US" sz="2800" dirty="0"/>
+          </a:p>
+        </p:txBody>
+      </p:sp>
+      <p:pic>
+        <p:nvPicPr>
+          <p:cNvPr id="11" name="Image 4" descr="art\seta.png">    </p:cNvPr>
+          <p:cNvPicPr>
+            <a:picLocks noChangeAspect="1"/>
+          </p:cNvPicPr>
+          <p:nvPr/>
+        </p:nvPicPr>
+        <p:blipFill>
+          <a:blip r:embed="rId5"/>
+          <a:stretch>
+            <a:fillRect/>
+          </a:stretch>
+        </p:blipFill>
+        <p:spPr>
+          <a:xfrm>
+            <a:off x="2423160" y="9203436"/>
+            <a:ext cx="475488" cy="411480"/>
+          </a:xfrm>
+          <a:prstGeom prst="rect">
+            <a:avLst/>
+          </a:prstGeom>
+        </p:spPr>
+      </p:pic>
+      <p:sp>
+        <p:nvSpPr>
+          <p:cNvPr id="12" name="Text 5"/>
+          <p:cNvSpPr txBox="1"/>
+          <p:nvPr/>
+        </p:nvSpPr>
+        <p:spPr>
+          <a:xfrm>
+            <a:off x="3337560" y="9075420"/>
+            <a:ext cx="17922240" cy="548640"/>
+          </a:xfrm>
+          <a:prstGeom prst="rect">
+            <a:avLst/>
+          </a:prstGeom>
+          <a:noFill/>
+          <a:ln/>
+        </p:spPr>
+        <p:txBody>
+          <a:bodyPr wrap="square" lIns="0" tIns="0" rIns="0" bIns="0" rtlCol="0" anchor="t"/>
+          <a:lstStyle/>
+          <a:p>
+            <a:pPr indent="0" marL="0">
+              <a:lnSpc>
+                <a:spcPct val="118000"/>
+              </a:lnSpc>
+              <a:buNone/>
+            </a:pPr>
+            <a:r>
+              <a:rPr lang="en-US" sz="2800" b="1" dirty="0">
+                <a:solidFill>
+                  <a:srgbClr val="F4F5F6"/>
+                </a:solidFill>
+                <a:latin typeface="Roboto" pitchFamily="34" charset="0"/>
+                <a:ea typeface="Roboto" pitchFamily="34" charset="-122"/>
+                <a:cs typeface="Roboto" pitchFamily="34" charset="-120"/>
+              </a:rPr>
+              <a:t>Com dado real dá para ver para onde o dinheiro está indo — e onde trocar de modelo compensa.</a:t>
+            </a:r>
+            <a:endParaRPr lang="en-US" sz="2800" dirty="0"/>
+          </a:p>
+        </p:txBody>
+      </p:sp>
+      <p:pic>
+        <p:nvPicPr>
+          <p:cNvPr id="13" name="Image 5" descr="art\seta.png">    </p:cNvPr>
+          <p:cNvPicPr>
+            <a:picLocks noChangeAspect="1"/>
+          </p:cNvPicPr>
+          <p:nvPr/>
+        </p:nvPicPr>
+        <p:blipFill>
+          <a:blip r:embed="rId6"/>
+          <a:stretch>
+            <a:fillRect/>
+          </a:stretch>
+        </p:blipFill>
+        <p:spPr>
+          <a:xfrm>
+            <a:off x="2423160" y="10757916"/>
+            <a:ext cx="475488" cy="411480"/>
+          </a:xfrm>
+          <a:prstGeom prst="rect">
+            <a:avLst/>
+          </a:prstGeom>
+        </p:spPr>
+      </p:pic>
+      <p:sp>
+        <p:nvSpPr>
+          <p:cNvPr id="14" name="Text 6"/>
+          <p:cNvSpPr txBox="1"/>
+          <p:nvPr/>
+        </p:nvSpPr>
+        <p:spPr>
+          <a:xfrm>
+            <a:off x="3337560" y="10629900"/>
+            <a:ext cx="17922240" cy="548640"/>
+          </a:xfrm>
+          <a:prstGeom prst="rect">
+            <a:avLst/>
+          </a:prstGeom>
+          <a:noFill/>
+          <a:ln/>
+        </p:spPr>
+        <p:txBody>
+          <a:bodyPr wrap="square" lIns="0" tIns="0" rIns="0" bIns="0" rtlCol="0" anchor="t"/>
+          <a:lstStyle/>
+          <a:p>
+            <a:pPr indent="0" marL="0">
+              <a:lnSpc>
+                <a:spcPct val="118000"/>
+              </a:lnSpc>
+              <a:buNone/>
+            </a:pPr>
+            <a:r>
+              <a:rPr lang="en-US" sz="2800" dirty="0">
+                <a:solidFill>
+                  <a:srgbClr val="A7A9B4"/>
+                </a:solidFill>
+                <a:latin typeface="Roboto" pitchFamily="34" charset="0"/>
+                <a:ea typeface="Roboto" pitchFamily="34" charset="-122"/>
+                <a:cs typeface="Roboto" pitchFamily="34" charset="-120"/>
+              </a:rPr>
+              <a:t>Quatro falhas documentadas, nenhuma descoberta por reclamação de usuário.</a:t>
+            </a:r>
+            <a:endParaRPr lang="en-US" sz="2800" dirty="0"/>
+          </a:p>
+        </p:txBody>
+      </p:sp>
+      <p:sp>
+        <p:nvSpPr>
+          <p:cNvPr id="15" name="Text 7"/>
+          <p:cNvSpPr txBox="1"/>
+          <p:nvPr/>
+        </p:nvSpPr>
+        <p:spPr>
+          <a:xfrm>
+            <a:off x="2423160" y="12755880"/>
+            <a:ext cx="19540728" cy="457200"/>
+          </a:xfrm>
+          <a:prstGeom prst="rect">
+            <a:avLst/>
+          </a:prstGeom>
+          <a:noFill/>
+          <a:ln/>
+        </p:spPr>
+        <p:txBody>
+          <a:bodyPr wrap="square" lIns="0" tIns="0" rIns="0" bIns="0" rtlCol="0" anchor="ctr"/>
+          <a:lstStyle/>
+          <a:p>
+            <a:pPr indent="0" marL="0">
+              <a:buNone/>
+            </a:pPr>
+            <a:r>
+              <a:rPr lang="en-US" sz="1500" dirty="0">
+                <a:solidFill>
+                  <a:srgbClr val="A7A9B4">
+                    <a:alpha val="65000"/>
+                  </a:srgbClr>
+                </a:solidFill>
+                <a:latin typeface="Roboto" pitchFamily="34" charset="0"/>
+                <a:ea typeface="Roboto" pitchFamily="34" charset="-122"/>
+                <a:cs typeface="Roboto" pitchFamily="34" charset="-120"/>
+              </a:rPr>
+              <a:t>Aula 3 — Observabilidade: monitorando em produção — Evals, observabilidade e conformidade</a:t>
+            </a:r>
+            <a:endParaRPr lang="en-US" sz="1500" dirty="0"/>
+          </a:p>
+        </p:txBody>
+      </p:sp>
+    </p:spTree>
+  </p:cSld>
+  <p:clrMapOvr>
+    <a:masterClrMapping/>
+  </p:clrMapOvr>
+</p:sld>
+</file>
+
+<file path=ppt/slides/slide21.xml><?xml version="1.0" encoding="utf-8"?>
+<p:sld xmlns:a="http://schemas.openxmlformats.org/drawingml/2006/main" xmlns:r="http://schemas.openxmlformats.org/officeDocument/2006/relationships" xmlns:p="http://schemas.openxmlformats.org/presentationml/2006/main">
+  <p:cSld name="Slide 21">
     <p:bg>
       <p:bgPr>
         <a:solidFill>

</xml_diff>